<commit_message>
docs: update build guide and performance report
</commit_message>
<xml_diff>
--- a/gs_format_converter算法流程.pptx
+++ b/gs_format_converter算法流程.pptx
@@ -2,20 +2,20 @@
 <file path=ppt/presentation.xml><?xml version="1.0" encoding="utf-8"?>
 <p:presentation xmlns:p="http://schemas.openxmlformats.org/presentationml/2006/main">
   <p:sldMasterIdLst>
-    <p:sldMasterId xmlns:r="http://schemas.openxmlformats.org/officeDocument/2006/relationships" id="2147483648" r:id="R23778b1f2d384d93"/>
+    <p:sldMasterId xmlns:r="http://schemas.openxmlformats.org/officeDocument/2006/relationships" id="2147483648" r:id="Rf65ebbcad4bb45ec"/>
   </p:sldMasterIdLst>
   <p:notesMasterIdLst>
-    <p:notesMasterId xmlns:r="http://schemas.openxmlformats.org/officeDocument/2006/relationships" r:id="R653f98ed3d2e4588"/>
+    <p:notesMasterId xmlns:r="http://schemas.openxmlformats.org/officeDocument/2006/relationships" r:id="R3caa73907fcc48f6"/>
   </p:notesMasterIdLst>
   <p:sldIdLst>
-    <p:sldId xmlns:r="http://schemas.openxmlformats.org/officeDocument/2006/relationships" id="256" r:id="R1304402ba60b40c9"/>
-    <p:sldId xmlns:r="http://schemas.openxmlformats.org/officeDocument/2006/relationships" id="257" r:id="Rabc0a15c4c4d44b3"/>
-    <p:sldId xmlns:r="http://schemas.openxmlformats.org/officeDocument/2006/relationships" id="258" r:id="R88579a99bf9c4267"/>
-    <p:sldId xmlns:r="http://schemas.openxmlformats.org/officeDocument/2006/relationships" id="259" r:id="R5890c32a9c8b4479"/>
-    <p:sldId xmlns:r="http://schemas.openxmlformats.org/officeDocument/2006/relationships" id="260" r:id="Raf1a180aae574a22"/>
-    <p:sldId xmlns:r="http://schemas.openxmlformats.org/officeDocument/2006/relationships" id="261" r:id="R9a6a775995d74fa4"/>
-    <p:sldId xmlns:r="http://schemas.openxmlformats.org/officeDocument/2006/relationships" id="262" r:id="R30cf230329ac4e33"/>
-    <p:sldId xmlns:r="http://schemas.openxmlformats.org/officeDocument/2006/relationships" id="263" r:id="R68929e3918d4447f"/>
+    <p:sldId xmlns:r="http://schemas.openxmlformats.org/officeDocument/2006/relationships" id="256" r:id="R2b96e481e8fa447c"/>
+    <p:sldId xmlns:r="http://schemas.openxmlformats.org/officeDocument/2006/relationships" id="257" r:id="R6fb438c01c71422d"/>
+    <p:sldId xmlns:r="http://schemas.openxmlformats.org/officeDocument/2006/relationships" id="258" r:id="R016005ac405a4e44"/>
+    <p:sldId xmlns:r="http://schemas.openxmlformats.org/officeDocument/2006/relationships" id="259" r:id="Rb8259fe8da1249a4"/>
+    <p:sldId xmlns:r="http://schemas.openxmlformats.org/officeDocument/2006/relationships" id="260" r:id="Ra871046e7c864741"/>
+    <p:sldId xmlns:r="http://schemas.openxmlformats.org/officeDocument/2006/relationships" id="261" r:id="R7a1085ae9d8949c9"/>
+    <p:sldId xmlns:r="http://schemas.openxmlformats.org/officeDocument/2006/relationships" id="262" r:id="R6d23825713804bee"/>
+    <p:sldId xmlns:r="http://schemas.openxmlformats.org/officeDocument/2006/relationships" id="263" r:id="R8a46373df8a8448e"/>
   </p:sldIdLst>
   <p:sldSz cx="12192000" cy="6858000"/>
   <p:notesSz cx="6858000" cy="9144000"/>
@@ -1047,7 +1047,7 @@
   </p:cSld>
   <p:clrMap bg1="lt1" tx1="dk1" bg2="lt2" tx2="dk2" accent1="accent1" accent2="accent2" accent3="accent3" accent4="accent4" accent5="accent5" accent6="accent6" hlink="hlink" folHlink="folHlink"/>
   <p:sldLayoutIdLst>
-    <p:sldLayoutId xmlns:r="http://schemas.openxmlformats.org/officeDocument/2006/relationships" id="2147483649" r:id="R57e08842b08d4de8"/>
+    <p:sldLayoutId xmlns:r="http://schemas.openxmlformats.org/officeDocument/2006/relationships" id="2147483649" r:id="R890862f392f641a9"/>
   </p:sldLayoutIdLst>
   <p:txStyles>
     <p:titleStyle>
@@ -2844,7 +2844,7 @@
       </p:sp>
       <p:cxnSp>
         <p:nvCxnSpPr>
-          <p:cNvPr id="49" name="flow-arrow-0"/>
+          <p:cNvPr id="61" name="flow-arrow-0"/>
           <p:cNvCxnSpPr/>
           <p:nvPr/>
         </p:nvCxnSpPr>
@@ -2866,7 +2866,7 @@
       </p:cxnSp>
       <p:cxnSp>
         <p:nvCxnSpPr>
-          <p:cNvPr id="50" name="flow-arrow-1"/>
+          <p:cNvPr id="62" name="flow-arrow-1"/>
           <p:cNvCxnSpPr/>
           <p:nvPr/>
         </p:nvCxnSpPr>
@@ -2888,7 +2888,7 @@
       </p:cxnSp>
       <p:cxnSp>
         <p:nvCxnSpPr>
-          <p:cNvPr id="51" name="flow-arrow-2"/>
+          <p:cNvPr id="63" name="flow-arrow-2"/>
           <p:cNvCxnSpPr/>
           <p:nvPr/>
         </p:nvCxnSpPr>
@@ -2910,7 +2910,7 @@
       </p:cxnSp>
       <p:cxnSp>
         <p:nvCxnSpPr>
-          <p:cNvPr id="52" name="flow-arrow-3"/>
+          <p:cNvPr id="64" name="flow-arrow-3"/>
           <p:cNvCxnSpPr/>
           <p:nvPr/>
         </p:nvCxnSpPr>
@@ -4491,7 +4491,7 @@
       </p:sp>
       <p:cxnSp>
         <p:nvCxnSpPr>
-          <p:cNvPr id="79" name="glb-a1"/>
+          <p:cNvPr id="105" name="glb-a1"/>
           <p:cNvCxnSpPr/>
           <p:nvPr/>
         </p:nvCxnSpPr>
@@ -4513,7 +4513,7 @@
       </p:cxnSp>
       <p:cxnSp>
         <p:nvCxnSpPr>
-          <p:cNvPr id="80" name="glb-a2"/>
+          <p:cNvPr id="106" name="glb-a2"/>
           <p:cNvCxnSpPr/>
           <p:nvPr/>
         </p:nvCxnSpPr>
@@ -5091,7 +5091,7 @@
       </p:sp>
       <p:cxnSp>
         <p:nvCxnSpPr>
-          <p:cNvPr id="105" name="map-a-0"/>
+          <p:cNvPr id="143" name="map-a-0"/>
           <p:cNvCxnSpPr/>
           <p:nvPr/>
         </p:nvCxnSpPr>
@@ -5293,7 +5293,7 @@
       </p:sp>
       <p:cxnSp>
         <p:nvCxnSpPr>
-          <p:cNvPr id="110" name="map-a-1"/>
+          <p:cNvPr id="148" name="map-a-1"/>
           <p:cNvCxnSpPr/>
           <p:nvPr/>
         </p:nvCxnSpPr>
@@ -5495,7 +5495,7 @@
       </p:sp>
       <p:cxnSp>
         <p:nvCxnSpPr>
-          <p:cNvPr id="115" name="map-a-2"/>
+          <p:cNvPr id="153" name="map-a-2"/>
           <p:cNvCxnSpPr/>
           <p:nvPr/>
         </p:nvCxnSpPr>
@@ -5650,7 +5650,7 @@
                 <a:ea typeface="Helvetica Neue"/>
                 <a:cs typeface="Helvetica Neue"/>
               </a:rPr>
-              <a:t>观看约束转换尊重已有目标扩展</a:t>
+              <a:t>观看约束转换同步迁移模型坐标系旋转</a:t>
             </a:r>
           </a:p>
         </p:txBody>
@@ -6251,7 +6251,7 @@
                 <a:ea typeface="Helvetica Neue"/>
                 <a:cs typeface="Helvetica Neue"/>
               </a:rPr>
-              <a:t>相机扩展</a:t>
+              <a:t>旋转与兼容</a:t>
             </a:r>
           </a:p>
         </p:txBody>
@@ -6310,7 +6310,7 @@
                 <a:ea typeface="Helvetica Neue"/>
                 <a:cs typeface="Helvetica Neue"/>
               </a:rPr>
-              <a:t>双扩展共存时：</a:t>
+              <a:t>0.4 → 1.0：</a:t>
             </a:r>
           </a:p>
           <a:p xmlns:a="http://schemas.openxmlformats.org/drawingml/2006/main">
@@ -6334,12 +6334,12 @@
                 <a:ea typeface="Helvetica Neue"/>
                 <a:cs typeface="Helvetica Neue"/>
               </a:rPr>
-              <a:t>保留目标格式扩展</a:t>
-            </a:r>
-          </a:p>
-          <a:p xmlns:a="http://schemas.openxmlformats.org/drawingml/2006/main">
-            <a:r>
-              <a:t>不转换、不覆盖</a:t>
+              <a:t>3×3 行优先矩阵</a:t>
+            </a:r>
+          </a:p>
+          <a:p xmlns:a="http://schemas.openxmlformats.org/drawingml/2006/main">
+            <a:r>
+              <a:t>→ nodes[0].rotation (xyzw)</a:t>
             </a:r>
           </a:p>
           <a:p xmlns:a="http://schemas.openxmlformats.org/drawingml/2006/main">
@@ -6387,7 +6387,7 @@
                 <a:ea typeface="Helvetica Neue"/>
                 <a:cs typeface="Helvetica Neue"/>
               </a:rPr>
-              <a:t>constraints → parameters：</a:t>
+              <a:t>1.0 → 0.4：</a:t>
             </a:r>
           </a:p>
           <a:p xmlns:a="http://schemas.openxmlformats.org/drawingml/2006/main">
@@ -6411,7 +6411,7 @@
                 <a:ea typeface="Helvetica Neue"/>
                 <a:cs typeface="Helvetica Neue"/>
               </a:rPr>
-              <a:t>仅 type = allocentricSixDof</a:t>
+              <a:t>rotation → 3×3；缺省用单位矩阵</a:t>
             </a:r>
           </a:p>
         </p:txBody>
@@ -6470,7 +6470,7 @@
                 <a:ea typeface="Helvetica Neue"/>
                 <a:cs typeface="Helvetica Neue"/>
               </a:rPr>
-              <a:t>只有 allocentricSixDof 可转为 UWA_viewing_parameters；未转换的扩展声明保持不变。</a:t>
+              <a:t>仅转换 allocentricSixDof；目标扩展已存在时不覆盖，未转换声明保持不变。</a:t>
             </a:r>
           </a:p>
         </p:txBody>
@@ -6617,7 +6617,7 @@
       </p:sp>
       <p:cxnSp>
         <p:nvCxnSpPr>
-          <p:cNvPr id="42" name="mp4-a1"/>
+          <p:cNvPr id="52" name="mp4-a1"/>
           <p:cNvCxnSpPr/>
           <p:nvPr/>
         </p:nvCxnSpPr>
@@ -6639,7 +6639,7 @@
       </p:cxnSp>
       <p:cxnSp>
         <p:nvCxnSpPr>
-          <p:cNvPr id="43" name="mp4-a2"/>
+          <p:cNvPr id="53" name="mp4-a2"/>
           <p:cNvCxnSpPr/>
           <p:nvPr/>
         </p:nvCxnSpPr>
@@ -6661,7 +6661,7 @@
       </p:cxnSp>
       <p:cxnSp>
         <p:nvCxnSpPr>
-          <p:cNvPr id="44" name="mp4-a3"/>
+          <p:cNvPr id="54" name="mp4-a3"/>
           <p:cNvCxnSpPr/>
           <p:nvPr/>
         </p:nvCxnSpPr>

</xml_diff>